<commit_message>
Add speaker script for the presentation; embed same notes in .pptx
Adds a standalone plain-text speaking script (one short paragraph per
slide, natural spoken Slovenian) for practicing the oral presentation,
and embeds the identical text as PowerPoint speaker notes on each
slide for use in Presenter View.

Co-Authored-By: Claude Sonnet 5 <noreply@anthropic.com>
Claude-Session: https://claude.ai/code/session_01WfbhprcsRcTaKACt5yP2La
</commit_message>
<xml_diff>
--- a/VR-AR-Predmet/predstavitev/Vzpon-predstavitev.pptx
+++ b/VR-AR-Predmet/predstavitev/Vzpon-predstavitev.pptx
@@ -514,7 +514,7 @@
           <a:p>
             <a:r>
               <a:rPr lang="en-US" dirty="0"/>
-              <a:t/>
+              <a:t>Pozdravljeni, moj projekt se imenuje Vzpon — Zgodba Šoštanjske elektrarne. Je VR aplikacija za predmet Razvijanje aplikacij virtualne in obogatene resničnosti, mentor je Rok Urbanc.</a:t>
             </a:r>
             <a:endParaRPr lang="en-US" dirty="0"/>
           </a:p>
@@ -602,7 +602,7 @@
           <a:p>
             <a:r>
               <a:rPr lang="en-US" dirty="0"/>
-              <a:t/>
+              <a:t>Dodana vrednost je varen dostop do sicer nedostopnega industrijskega prostora, izkustvena pot do zgodovine slovenske energetike, in možnost uporabe pri postopnem soočanju s strahom pred višino.</a:t>
             </a:r>
             <a:endParaRPr lang="en-US" dirty="0"/>
           </a:p>
@@ -690,7 +690,7 @@
           <a:p>
             <a:r>
               <a:rPr lang="en-US" dirty="0"/>
-              <a:t/>
+              <a:t>Trenutno gre za Canvas2D pogon, ne pravi WebGL, in aplikacija še ni bila testirana na dejanski Meta Quest napravi. Za končno oddajo načrtujem celoten vzpon, več info-točk in zvok.</a:t>
             </a:r>
             <a:endParaRPr lang="en-US" dirty="0"/>
           </a:p>
@@ -778,7 +778,7 @@
           <a:p>
             <a:r>
               <a:rPr lang="en-US" dirty="0"/>
-              <a:t/>
+              <a:t>Celoten projekt je na GitHubu, organiziran po vajah — ideja, scene, tehnična zasnova — in nato prototip, ki je glavni del tega, kar sem danes pokazal.</a:t>
             </a:r>
             <a:endParaRPr lang="en-US" dirty="0"/>
           </a:p>
@@ -866,7 +866,7 @@
           <a:p>
             <a:r>
               <a:rPr lang="en-US" dirty="0"/>
-              <a:t/>
+              <a:t>Hvala za pozornost. Z veseljem odgovorim na vprašanja.</a:t>
             </a:r>
             <a:endParaRPr lang="en-US" dirty="0"/>
           </a:p>
@@ -954,7 +954,7 @@
           <a:p>
             <a:r>
               <a:rPr lang="en-US" dirty="0"/>
-              <a:t/>
+              <a:t>Hladilni stolp in dimnik TEŠ sta iz varnostnih razlogov zaprta za javnost, fizičen vzpon pa bi bil za večino prenevaren. Hkrati je zgodovina slovenske energetike predstavljena le na muzejskih tablah — ne kot nekaj, kar bi lahko doživeli. Zato sem naredil VR izkušnjo, ki uporabniku omogoči varen navidezni vzpon, med katerim spozna zgodovino elektrarne.</a:t>
             </a:r>
             <a:endParaRPr lang="en-US" dirty="0"/>
           </a:p>
@@ -1042,7 +1042,7 @@
           <a:p>
             <a:r>
               <a:rPr lang="en-US" dirty="0"/>
-              <a:t/>
+              <a:t>Aplikacija je namenjena štirim skupinam: šolam pri urah tehnike in zgodovine, turistom, ki jih zanima industrijska dediščina, ljudem s strahom pred višino za postopno izpostavljenostno terapijo, in zaposlenim v TEŠ pri uvajanju pred delom na višini.</a:t>
             </a:r>
             <a:endParaRPr lang="en-US" dirty="0"/>
           </a:p>
@@ -1130,7 +1130,7 @@
           <a:p>
             <a:r>
               <a:rPr lang="en-US" dirty="0"/>
-              <a:t/>
+              <a:t>Uporabnik pleza po zunanji konstrukciji elektrarne. Ob kontrolnih točkah se med vzponom odpre zgodovina gradnje, na vrhu pa stopi na galerijo okoli odprtega žrela hladilnega stolpa — z razgledom na dolino in naravnim učinkom vrtoglavice.</a:t>
             </a:r>
             <a:endParaRPr lang="en-US" dirty="0"/>
           </a:p>
@@ -1218,7 +1218,7 @@
           <a:p>
             <a:r>
               <a:rPr lang="en-US" dirty="0"/>
-              <a:t/>
+              <a:t>Gibanje je z WASD tipkami in miško za pogled. Ob steni stolpa se gibanje spremeni v plezanje. Med vzponom se prikažejo zgodovinske info-točke, na vrhu pa je galerija okoli odprtega žrela s sistemom, ki v realnem času prikazuje doseženo višino.</a:t>
             </a:r>
             <a:endParaRPr lang="en-US" dirty="0"/>
           </a:p>
@@ -1306,7 +1306,7 @@
           <a:p>
             <a:r>
               <a:rPr lang="en-US" dirty="0"/>
-              <a:t/>
+              <a:t>Aplikacija je zasnovana za WebXR — teče neposredno v brskalniku, tudi na Meta Quest napravi, brez namestitve. Unreal Engine sem opustil sredi projekta zaradi hitrosti razvoja. WebGL sem namenoma izpustil in namesto tega ročno napisal lasten Canvas2D 3D pogon.</a:t>
             </a:r>
             <a:endParaRPr lang="en-US" dirty="0"/>
           </a:p>
@@ -1394,7 +1394,7 @@
           <a:p>
             <a:r>
               <a:rPr lang="en-US" dirty="0"/>
-              <a:t/>
+              <a:t>Ves 3D svet izračunam ročno na navadnem 2D platnu — vsaka točka gre skozi pravo perspektivno projekcijo. Ker Canvas2D nima globinskega bufferja, ploskve sam sortiram od najbolj oddaljenih do najbližjih. Stolp ima pravo hiperboloidno obliko, je votel, in ima gladko senčenje, da lupina deluje ukrivljeno, ne kot niz ravnih plošč.</a:t>
             </a:r>
             <a:endParaRPr lang="en-US" dirty="0"/>
           </a:p>
@@ -1482,7 +1482,7 @@
           <a:p>
             <a:r>
               <a:rPr lang="en-US" dirty="0"/>
-              <a:t/>
+              <a:t>Tu je vznožje stolpa s kotlovnico, strojnico in dimnikom, ter pogled med samim vzponom, kjer lestev sledi ukrivljeni obliki stene.</a:t>
             </a:r>
             <a:endParaRPr lang="en-US" dirty="0"/>
           </a:p>
@@ -1570,7 +1570,7 @@
           <a:p>
             <a:r>
               <a:rPr lang="en-US" dirty="0"/>
-              <a:t/>
+              <a:t>Na vrhu je razgled na Šaleško dolino z gozdnatimi grebeni in Velenjskim jezerom. Spodaj je pogled v samo odprto žrelo stolpa, iz katerega se dviga para — tako kot pri pravem TEŠ, kjer je stolp v resnici votel s steno debelo le 18 centimetrov.</a:t>
             </a:r>
             <a:endParaRPr lang="en-US" dirty="0"/>
           </a:p>
@@ -2766,7 +2766,7 @@
       </p:sp>
       <p:sp>
         <p:nvSpPr>
-          <p:cNvPr id="20" name="Text 18"/>
+          <p:cNvPr id="21" name="Text 18"/>
           <p:cNvSpPr/>
           <p:nvPr/>
         </p:nvSpPr>
@@ -2805,7 +2805,7 @@
       </p:sp>
       <p:sp>
         <p:nvSpPr>
-          <p:cNvPr id="21" name="Text 19"/>
+          <p:cNvPr id="22" name="Text 19"/>
           <p:cNvSpPr/>
           <p:nvPr/>
         </p:nvSpPr>
@@ -3204,7 +3204,7 @@
       </p:sp>
       <p:sp>
         <p:nvSpPr>
-          <p:cNvPr id="9" name="Text 7"/>
+          <p:cNvPr id="10" name="Text 7"/>
           <p:cNvSpPr/>
           <p:nvPr/>
         </p:nvSpPr>
@@ -3243,7 +3243,7 @@
       </p:sp>
       <p:sp>
         <p:nvSpPr>
-          <p:cNvPr id="10" name="Text 8"/>
+          <p:cNvPr id="11" name="Text 8"/>
           <p:cNvSpPr/>
           <p:nvPr/>
         </p:nvSpPr>
@@ -3663,7 +3663,7 @@
       </p:sp>
       <p:sp>
         <p:nvSpPr>
-          <p:cNvPr id="8" name="Text 6"/>
+          <p:cNvPr id="9" name="Text 6"/>
           <p:cNvSpPr/>
           <p:nvPr/>
         </p:nvSpPr>
@@ -3702,7 +3702,7 @@
       </p:sp>
       <p:sp>
         <p:nvSpPr>
-          <p:cNvPr id="9" name="Text 7"/>
+          <p:cNvPr id="10" name="Text 7"/>
           <p:cNvSpPr/>
           <p:nvPr/>
         </p:nvSpPr>
@@ -4516,7 +4516,7 @@
       </p:sp>
       <p:sp>
         <p:nvSpPr>
-          <p:cNvPr id="19" name="Text 17"/>
+          <p:cNvPr id="20" name="Text 17"/>
           <p:cNvSpPr/>
           <p:nvPr/>
         </p:nvSpPr>
@@ -4555,7 +4555,7 @@
       </p:sp>
       <p:sp>
         <p:nvSpPr>
-          <p:cNvPr id="20" name="Text 18"/>
+          <p:cNvPr id="21" name="Text 18"/>
           <p:cNvSpPr/>
           <p:nvPr/>
         </p:nvSpPr>
@@ -5303,7 +5303,7 @@
       </p:sp>
       <p:sp>
         <p:nvSpPr>
-          <p:cNvPr id="21" name="Text 19"/>
+          <p:cNvPr id="22" name="Text 19"/>
           <p:cNvSpPr/>
           <p:nvPr/>
         </p:nvSpPr>
@@ -5342,7 +5342,7 @@
       </p:sp>
       <p:sp>
         <p:nvSpPr>
-          <p:cNvPr id="22" name="Text 20"/>
+          <p:cNvPr id="23" name="Text 20"/>
           <p:cNvSpPr/>
           <p:nvPr/>
         </p:nvSpPr>
@@ -6332,7 +6332,7 @@
       </p:sp>
       <p:sp>
         <p:nvSpPr>
-          <p:cNvPr id="29" name="Text 27"/>
+          <p:cNvPr id="30" name="Text 27"/>
           <p:cNvSpPr/>
           <p:nvPr/>
         </p:nvSpPr>
@@ -6371,7 +6371,7 @@
       </p:sp>
       <p:sp>
         <p:nvSpPr>
-          <p:cNvPr id="30" name="Text 28"/>
+          <p:cNvPr id="31" name="Text 28"/>
           <p:cNvSpPr/>
           <p:nvPr/>
         </p:nvSpPr>
@@ -7177,7 +7177,7 @@
       </p:sp>
       <p:sp>
         <p:nvSpPr>
-          <p:cNvPr id="20" name="Text 18"/>
+          <p:cNvPr id="21" name="Text 18"/>
           <p:cNvSpPr/>
           <p:nvPr/>
         </p:nvSpPr>
@@ -7216,7 +7216,7 @@
       </p:sp>
       <p:sp>
         <p:nvSpPr>
-          <p:cNvPr id="21" name="Text 19"/>
+          <p:cNvPr id="22" name="Text 19"/>
           <p:cNvSpPr/>
           <p:nvPr/>
         </p:nvSpPr>
@@ -7863,7 +7863,7 @@
       </p:sp>
       <p:sp>
         <p:nvSpPr>
-          <p:cNvPr id="18" name="Text 16"/>
+          <p:cNvPr id="19" name="Text 16"/>
           <p:cNvSpPr/>
           <p:nvPr/>
         </p:nvSpPr>
@@ -7902,7 +7902,7 @@
       </p:sp>
       <p:sp>
         <p:nvSpPr>
-          <p:cNvPr id="19" name="Text 17"/>
+          <p:cNvPr id="20" name="Text 17"/>
           <p:cNvSpPr/>
           <p:nvPr/>
         </p:nvSpPr>
@@ -8811,7 +8811,7 @@
       </p:sp>
       <p:sp>
         <p:nvSpPr>
-          <p:cNvPr id="21" name="Text 19"/>
+          <p:cNvPr id="22" name="Text 19"/>
           <p:cNvSpPr/>
           <p:nvPr/>
         </p:nvSpPr>
@@ -8850,7 +8850,7 @@
       </p:sp>
       <p:sp>
         <p:nvSpPr>
-          <p:cNvPr id="22" name="Text 20"/>
+          <p:cNvPr id="23" name="Text 20"/>
           <p:cNvSpPr/>
           <p:nvPr/>
         </p:nvSpPr>

</xml_diff>